<commit_message>
Regenerate examples with fit measured in the deck's own fonts
Rendered with PowerPoint. Boxes are sized to the theme's Calibri plus
textmargin on each side, and the drop shadows gone since cfdfdc0 are
gone here too.
</commit_message>
<xml_diff>
--- a/examples/pipeline.pptx
+++ b/examples/pipeline.pptx
@@ -7,7 +7,7 @@
   <p:sldIdLst>
     <p:sldId id="256" r:id="rId7"/>
   </p:sldIdLst>
-  <p:sldSz cx="2761734" cy="1327785" type="screen4x3"/>
+  <p:sldSz cx="2827411" cy="1327785" type="screen4x3"/>
   <p:notesSz cx="6858000" cy="9144000"/>
   <p:defaultTextStyle>
     <a:defPPr>
@@ -3109,6 +3109,7 @@
             <a:headEnd type="none"/>
             <a:tailEnd type="triangle"/>
           </a:ln>
+          <a:effectLst/>
         </p:spPr>
         <p:style>
           <a:lnRef idx="2">
@@ -3133,8 +3134,8 @@
         </p:nvSpPr>
         <p:spPr>
           <a:xfrm>
-            <a:off x="220980" y="137160"/>
-            <a:ext cx="746760" cy="153352"/>
+            <a:off x="301056" y="137160"/>
+            <a:ext cx="586606" cy="153352"/>
           </a:xfrm>
           <a:prstGeom prst="rect">
             <a:avLst/>
@@ -3169,8 +3170,8 @@
         </p:nvSpPr>
         <p:spPr>
           <a:xfrm>
-            <a:off x="314325" y="350520"/>
-            <a:ext cx="560069" cy="153352"/>
+            <a:off x="301056" y="350520"/>
+            <a:ext cx="586606" cy="153352"/>
           </a:xfrm>
           <a:prstGeom prst="rect">
             <a:avLst/>
@@ -3206,7 +3207,7 @@
         <p:spPr>
           <a:xfrm>
             <a:off x="1051560" y="137160"/>
-            <a:ext cx="658614" cy="366712"/>
+            <a:ext cx="724291" cy="366712"/>
           </a:xfrm>
           <a:prstGeom prst="roundRect">
             <a:avLst>
@@ -3219,6 +3220,7 @@
               <a:srgbClr val="000000"/>
             </a:solidFill>
           </a:ln>
+          <a:effectLst/>
         </p:spPr>
         <p:style>
           <a:lnRef idx="1">
@@ -3235,7 +3237,7 @@
           </a:fontRef>
         </p:style>
         <p:txBody>
-          <a:bodyPr rtlCol="0" anchor="ctr" wrap="none" lIns="0" rIns="0" tIns="0" bIns="0"/>
+          <a:bodyPr rtlCol="0" anchor="ctr" wrap="none" tIns="0" bIns="0"/>
           <a:lstStyle/>
           <a:p>
             <a:pPr algn="ctr"/>
@@ -3273,7 +3275,7 @@
         </p:nvCxnSpPr>
         <p:spPr>
           <a:xfrm>
-            <a:off x="1710174" y="320516"/>
+            <a:off x="1775851" y="320516"/>
             <a:ext cx="914400" cy="0"/>
           </a:xfrm>
           <a:prstGeom prst="line">
@@ -3286,6 +3288,7 @@
             <a:headEnd type="none"/>
             <a:tailEnd type="triangle"/>
           </a:ln>
+          <a:effectLst/>
         </p:spPr>
         <p:style>
           <a:lnRef idx="2">
@@ -3310,8 +3313,8 @@
         </p:nvSpPr>
         <p:spPr>
           <a:xfrm>
-            <a:off x="1980684" y="137160"/>
-            <a:ext cx="373379" cy="153352"/>
+            <a:off x="2039116" y="137160"/>
+            <a:ext cx="387870" cy="153352"/>
           </a:xfrm>
           <a:prstGeom prst="rect">
             <a:avLst/>
@@ -3346,8 +3349,8 @@
         </p:nvSpPr>
         <p:spPr>
           <a:xfrm>
-            <a:off x="1887339" y="350520"/>
-            <a:ext cx="560069" cy="153352"/>
+            <a:off x="2039116" y="350520"/>
+            <a:ext cx="387870" cy="153352"/>
           </a:xfrm>
           <a:prstGeom prst="rect">
             <a:avLst/>
@@ -3382,7 +3385,7 @@
         </p:nvCxnSpPr>
         <p:spPr>
           <a:xfrm>
-            <a:off x="1380867" y="503872"/>
+            <a:off x="1413705" y="503872"/>
             <a:ext cx="0" cy="320040"/>
           </a:xfrm>
           <a:prstGeom prst="line">
@@ -3395,6 +3398,7 @@
             <a:headEnd type="triangle"/>
             <a:tailEnd type="none"/>
           </a:ln>
+          <a:effectLst/>
         </p:spPr>
         <p:style>
           <a:lnRef idx="2">
@@ -3419,8 +3423,8 @@
         </p:nvSpPr>
         <p:spPr>
           <a:xfrm>
-            <a:off x="1058505" y="823912"/>
-            <a:ext cx="644723" cy="366712"/>
+            <a:off x="1064892" y="823912"/>
+            <a:ext cx="697626" cy="366712"/>
           </a:xfrm>
           <a:prstGeom prst="foldedCorner">
             <a:avLst/>
@@ -3431,6 +3435,7 @@
               <a:srgbClr val="000000"/>
             </a:solidFill>
           </a:ln>
+          <a:effectLst/>
         </p:spPr>
         <p:style>
           <a:lnRef idx="1">
@@ -3447,7 +3452,7 @@
           </a:fontRef>
         </p:style>
         <p:txBody>
-          <a:bodyPr rtlCol="0" anchor="ctr" wrap="none" lIns="0" rIns="0" tIns="0" bIns="0"/>
+          <a:bodyPr rtlCol="0" anchor="ctr" wrap="none" tIns="0" bIns="0"/>
           <a:lstStyle/>
           <a:p>
             <a:pPr algn="ctr"/>

</xml_diff>